<commit_message>
feature/dell-laptop-stashed-changes: Reading Word Group One Quiz. Chandrabindu image instead of text attempt.
</commit_message>
<xml_diff>
--- a/Misc Files/mojaru - 4 - pronunciation.pptx
+++ b/Misc Files/mojaru - 4 - pronunciation.pptx
@@ -183,7 +183,7 @@
           <a:noFill/>
           <a:extLst>
             <a:ext uri="{909E8E84-426E-40dd-AFC4-6F175D3DCCD1}">
-              <a14:hiddenFill xmlns:a14="http://schemas.microsoft.com/office/drawing/2010/main" xmlns="">
+              <a14:hiddenFill xmlns="" xmlns:a14="http://schemas.microsoft.com/office/drawing/2010/main">
                 <a:solidFill>
                   <a:srgbClr val="FFFFFF"/>
                 </a:solidFill>
@@ -243,7 +243,7 @@
             </a:ln>
             <a:extLst>
               <a:ext uri="{91240B29-F687-4f45-9708-019B960494DF}">
-                <a14:hiddenLine xmlns:a14="http://schemas.microsoft.com/office/drawing/2010/main" xmlns="" w="9525">
+                <a14:hiddenLine xmlns="" xmlns:a14="http://schemas.microsoft.com/office/drawing/2010/main" w="9525">
                   <a:solidFill>
                     <a:srgbClr val="000000"/>
                   </a:solidFill>
@@ -333,7 +333,7 @@
             </a:ln>
             <a:extLst>
               <a:ext uri="{91240B29-F687-4f45-9708-019B960494DF}">
-                <a14:hiddenLine xmlns:a14="http://schemas.microsoft.com/office/drawing/2010/main" xmlns="" w="9525">
+                <a14:hiddenLine xmlns="" xmlns:a14="http://schemas.microsoft.com/office/drawing/2010/main" w="9525">
                   <a:solidFill>
                     <a:srgbClr val="000000"/>
                   </a:solidFill>
@@ -423,7 +423,7 @@
             </a:ln>
             <a:extLst>
               <a:ext uri="{91240B29-F687-4f45-9708-019B960494DF}">
-                <a14:hiddenLine xmlns:a14="http://schemas.microsoft.com/office/drawing/2010/main" xmlns="" w="9525">
+                <a14:hiddenLine xmlns="" xmlns:a14="http://schemas.microsoft.com/office/drawing/2010/main" w="9525">
                   <a:solidFill>
                     <a:srgbClr val="000000"/>
                   </a:solidFill>
@@ -457,7 +457,7 @@
             </a:ln>
             <a:extLst>
               <a:ext uri="{91240B29-F687-4f45-9708-019B960494DF}">
-                <a14:hiddenLine xmlns:a14="http://schemas.microsoft.com/office/drawing/2010/main" xmlns="" w="9525">
+                <a14:hiddenLine xmlns="" xmlns:a14="http://schemas.microsoft.com/office/drawing/2010/main" w="9525">
                   <a:solidFill>
                     <a:srgbClr val="000000"/>
                   </a:solidFill>
@@ -547,7 +547,7 @@
             </a:ln>
             <a:extLst>
               <a:ext uri="{91240B29-F687-4f45-9708-019B960494DF}">
-                <a14:hiddenLine xmlns:a14="http://schemas.microsoft.com/office/drawing/2010/main" xmlns="" w="9525">
+                <a14:hiddenLine xmlns="" xmlns:a14="http://schemas.microsoft.com/office/drawing/2010/main" w="9525">
                   <a:solidFill>
                     <a:srgbClr val="000000"/>
                   </a:solidFill>
@@ -609,7 +609,7 @@
             </a:ln>
             <a:extLst>
               <a:ext uri="{91240B29-F687-4f45-9708-019B960494DF}">
-                <a14:hiddenLine xmlns:a14="http://schemas.microsoft.com/office/drawing/2010/main" xmlns="" w="9525">
+                <a14:hiddenLine xmlns="" xmlns:a14="http://schemas.microsoft.com/office/drawing/2010/main" w="9525">
                   <a:solidFill>
                     <a:srgbClr val="000000"/>
                   </a:solidFill>
@@ -671,7 +671,7 @@
             </a:ln>
             <a:extLst>
               <a:ext uri="{91240B29-F687-4f45-9708-019B960494DF}">
-                <a14:hiddenLine xmlns:a14="http://schemas.microsoft.com/office/drawing/2010/main" xmlns="" w="9525">
+                <a14:hiddenLine xmlns="" xmlns:a14="http://schemas.microsoft.com/office/drawing/2010/main" w="9525">
                   <a:solidFill>
                     <a:srgbClr val="000000"/>
                   </a:solidFill>
@@ -761,7 +761,7 @@
             </a:ln>
             <a:extLst>
               <a:ext uri="{91240B29-F687-4f45-9708-019B960494DF}">
-                <a14:hiddenLine xmlns:a14="http://schemas.microsoft.com/office/drawing/2010/main" xmlns="" w="9525">
+                <a14:hiddenLine xmlns="" xmlns:a14="http://schemas.microsoft.com/office/drawing/2010/main" w="9525">
                   <a:solidFill>
                     <a:srgbClr val="000000"/>
                   </a:solidFill>
@@ -823,7 +823,7 @@
             </a:ln>
             <a:extLst>
               <a:ext uri="{91240B29-F687-4f45-9708-019B960494DF}">
-                <a14:hiddenLine xmlns:a14="http://schemas.microsoft.com/office/drawing/2010/main" xmlns="" w="9525">
+                <a14:hiddenLine xmlns="" xmlns:a14="http://schemas.microsoft.com/office/drawing/2010/main" w="9525">
                   <a:solidFill>
                     <a:srgbClr val="000000"/>
                   </a:solidFill>
@@ -885,7 +885,7 @@
             </a:ln>
             <a:extLst>
               <a:ext uri="{91240B29-F687-4f45-9708-019B960494DF}">
-                <a14:hiddenLine xmlns:a14="http://schemas.microsoft.com/office/drawing/2010/main" xmlns="" w="9525">
+                <a14:hiddenLine xmlns="" xmlns:a14="http://schemas.microsoft.com/office/drawing/2010/main" w="9525">
                   <a:solidFill>
                     <a:srgbClr val="000000"/>
                   </a:solidFill>
@@ -975,7 +975,7 @@
             </a:ln>
             <a:extLst>
               <a:ext uri="{91240B29-F687-4f45-9708-019B960494DF}">
-                <a14:hiddenLine xmlns:a14="http://schemas.microsoft.com/office/drawing/2010/main" xmlns="" w="9525">
+                <a14:hiddenLine xmlns="" xmlns:a14="http://schemas.microsoft.com/office/drawing/2010/main" w="9525">
                   <a:solidFill>
                     <a:srgbClr val="000000"/>
                   </a:solidFill>
@@ -1065,7 +1065,7 @@
             </a:ln>
             <a:extLst>
               <a:ext uri="{91240B29-F687-4f45-9708-019B960494DF}">
-                <a14:hiddenLine xmlns:a14="http://schemas.microsoft.com/office/drawing/2010/main" xmlns="" w="9525">
+                <a14:hiddenLine xmlns="" xmlns:a14="http://schemas.microsoft.com/office/drawing/2010/main" w="9525">
                   <a:solidFill>
                     <a:srgbClr val="000000"/>
                   </a:solidFill>
@@ -1127,7 +1127,7 @@
             </a:ln>
             <a:extLst>
               <a:ext uri="{91240B29-F687-4f45-9708-019B960494DF}">
-                <a14:hiddenLine xmlns:a14="http://schemas.microsoft.com/office/drawing/2010/main" xmlns="" w="9525">
+                <a14:hiddenLine xmlns="" xmlns:a14="http://schemas.microsoft.com/office/drawing/2010/main" w="9525">
                   <a:solidFill>
                     <a:srgbClr val="000000"/>
                   </a:solidFill>
@@ -1237,7 +1237,7 @@
             </a:ln>
             <a:extLst>
               <a:ext uri="{91240B29-F687-4f45-9708-019B960494DF}">
-                <a14:hiddenLine xmlns:a14="http://schemas.microsoft.com/office/drawing/2010/main" xmlns="" w="9525">
+                <a14:hiddenLine xmlns="" xmlns:a14="http://schemas.microsoft.com/office/drawing/2010/main" w="9525">
                   <a:solidFill>
                     <a:srgbClr val="000000"/>
                   </a:solidFill>
@@ -1299,7 +1299,7 @@
             </a:ln>
             <a:extLst>
               <a:ext uri="{91240B29-F687-4f45-9708-019B960494DF}">
-                <a14:hiddenLine xmlns:a14="http://schemas.microsoft.com/office/drawing/2010/main" xmlns="" w="9525">
+                <a14:hiddenLine xmlns="" xmlns:a14="http://schemas.microsoft.com/office/drawing/2010/main" w="9525">
                   <a:solidFill>
                     <a:srgbClr val="000000"/>
                   </a:solidFill>
@@ -1389,7 +1389,7 @@
             </a:ln>
             <a:extLst>
               <a:ext uri="{91240B29-F687-4f45-9708-019B960494DF}">
-                <a14:hiddenLine xmlns:a14="http://schemas.microsoft.com/office/drawing/2010/main" xmlns="" w="9525">
+                <a14:hiddenLine xmlns="" xmlns:a14="http://schemas.microsoft.com/office/drawing/2010/main" w="9525">
                   <a:solidFill>
                     <a:srgbClr val="000000"/>
                   </a:solidFill>
@@ -1479,7 +1479,7 @@
             </a:ln>
             <a:extLst>
               <a:ext uri="{91240B29-F687-4f45-9708-019B960494DF}">
-                <a14:hiddenLine xmlns:a14="http://schemas.microsoft.com/office/drawing/2010/main" xmlns="" w="9525">
+                <a14:hiddenLine xmlns="" xmlns:a14="http://schemas.microsoft.com/office/drawing/2010/main" w="9525">
                   <a:solidFill>
                     <a:srgbClr val="000000"/>
                   </a:solidFill>
@@ -1541,7 +1541,7 @@
             </a:ln>
             <a:extLst>
               <a:ext uri="{91240B29-F687-4f45-9708-019B960494DF}">
-                <a14:hiddenLine xmlns:a14="http://schemas.microsoft.com/office/drawing/2010/main" xmlns="" w="9525">
+                <a14:hiddenLine xmlns="" xmlns:a14="http://schemas.microsoft.com/office/drawing/2010/main" w="9525">
                   <a:solidFill>
                     <a:srgbClr val="000000"/>
                   </a:solidFill>
@@ -1631,7 +1631,7 @@
             </a:ln>
             <a:extLst>
               <a:ext uri="{91240B29-F687-4f45-9708-019B960494DF}">
-                <a14:hiddenLine xmlns:a14="http://schemas.microsoft.com/office/drawing/2010/main" xmlns="" w="9525">
+                <a14:hiddenLine xmlns="" xmlns:a14="http://schemas.microsoft.com/office/drawing/2010/main" w="9525">
                   <a:solidFill>
                     <a:srgbClr val="000000"/>
                   </a:solidFill>
@@ -1721,7 +1721,7 @@
             </a:ln>
             <a:extLst>
               <a:ext uri="{91240B29-F687-4f45-9708-019B960494DF}">
-                <a14:hiddenLine xmlns:a14="http://schemas.microsoft.com/office/drawing/2010/main" xmlns="" w="9525">
+                <a14:hiddenLine xmlns="" xmlns:a14="http://schemas.microsoft.com/office/drawing/2010/main" w="9525">
                   <a:solidFill>
                     <a:srgbClr val="000000"/>
                   </a:solidFill>
@@ -1777,7 +1777,7 @@
             </a:ln>
             <a:extLst>
               <a:ext uri="{91240B29-F687-4f45-9708-019B960494DF}">
-                <a14:hiddenLine xmlns:a14="http://schemas.microsoft.com/office/drawing/2010/main" xmlns="" w="9525">
+                <a14:hiddenLine xmlns="" xmlns:a14="http://schemas.microsoft.com/office/drawing/2010/main" w="9525">
                   <a:solidFill>
                     <a:srgbClr val="000000"/>
                   </a:solidFill>
@@ -1867,7 +1867,7 @@
             </a:ln>
             <a:extLst>
               <a:ext uri="{91240B29-F687-4f45-9708-019B960494DF}">
-                <a14:hiddenLine xmlns:a14="http://schemas.microsoft.com/office/drawing/2010/main" xmlns="" w="9525">
+                <a14:hiddenLine xmlns="" xmlns:a14="http://schemas.microsoft.com/office/drawing/2010/main" w="9525">
                   <a:solidFill>
                     <a:srgbClr val="000000"/>
                   </a:solidFill>
@@ -1923,7 +1923,7 @@
             </a:ln>
             <a:extLst>
               <a:ext uri="{91240B29-F687-4f45-9708-019B960494DF}">
-                <a14:hiddenLine xmlns:a14="http://schemas.microsoft.com/office/drawing/2010/main" xmlns="" w="9525">
+                <a14:hiddenLine xmlns="" xmlns:a14="http://schemas.microsoft.com/office/drawing/2010/main" w="9525">
                   <a:solidFill>
                     <a:srgbClr val="000000"/>
                   </a:solidFill>
@@ -2013,7 +2013,7 @@
             </a:ln>
             <a:extLst>
               <a:ext uri="{91240B29-F687-4f45-9708-019B960494DF}">
-                <a14:hiddenLine xmlns:a14="http://schemas.microsoft.com/office/drawing/2010/main" xmlns="" w="9525">
+                <a14:hiddenLine xmlns="" xmlns:a14="http://schemas.microsoft.com/office/drawing/2010/main" w="9525">
                   <a:solidFill>
                     <a:srgbClr val="000000"/>
                   </a:solidFill>
@@ -2081,7 +2081,7 @@
             </a:ln>
             <a:extLst>
               <a:ext uri="{91240B29-F687-4f45-9708-019B960494DF}">
-                <a14:hiddenLine xmlns:a14="http://schemas.microsoft.com/office/drawing/2010/main" xmlns="" w="9525">
+                <a14:hiddenLine xmlns="" xmlns:a14="http://schemas.microsoft.com/office/drawing/2010/main" w="9525">
                   <a:solidFill>
                     <a:srgbClr val="000000"/>
                   </a:solidFill>
@@ -2171,7 +2171,7 @@
             </a:ln>
             <a:extLst>
               <a:ext uri="{91240B29-F687-4f45-9708-019B960494DF}">
-                <a14:hiddenLine xmlns:a14="http://schemas.microsoft.com/office/drawing/2010/main" xmlns="" w="9525">
+                <a14:hiddenLine xmlns="" xmlns:a14="http://schemas.microsoft.com/office/drawing/2010/main" w="9525">
                   <a:solidFill>
                     <a:srgbClr val="000000"/>
                   </a:solidFill>
@@ -2239,7 +2239,7 @@
             </a:ln>
             <a:extLst>
               <a:ext uri="{91240B29-F687-4f45-9708-019B960494DF}">
-                <a14:hiddenLine xmlns:a14="http://schemas.microsoft.com/office/drawing/2010/main" xmlns="" w="9525">
+                <a14:hiddenLine xmlns="" xmlns:a14="http://schemas.microsoft.com/office/drawing/2010/main" w="9525">
                   <a:solidFill>
                     <a:srgbClr val="000000"/>
                   </a:solidFill>
@@ -2329,7 +2329,7 @@
             </a:ln>
             <a:extLst>
               <a:ext uri="{91240B29-F687-4f45-9708-019B960494DF}">
-                <a14:hiddenLine xmlns:a14="http://schemas.microsoft.com/office/drawing/2010/main" xmlns="" w="9525">
+                <a14:hiddenLine xmlns="" xmlns:a14="http://schemas.microsoft.com/office/drawing/2010/main" w="9525">
                   <a:solidFill>
                     <a:srgbClr val="000000"/>
                   </a:solidFill>
@@ -2363,7 +2363,7 @@
             </a:ln>
             <a:extLst>
               <a:ext uri="{91240B29-F687-4f45-9708-019B960494DF}">
-                <a14:hiddenLine xmlns:a14="http://schemas.microsoft.com/office/drawing/2010/main" xmlns="" w="9525">
+                <a14:hiddenLine xmlns="" xmlns:a14="http://schemas.microsoft.com/office/drawing/2010/main" w="9525">
                   <a:solidFill>
                     <a:srgbClr val="000000"/>
                   </a:solidFill>
@@ -2453,7 +2453,7 @@
             </a:ln>
             <a:extLst>
               <a:ext uri="{91240B29-F687-4f45-9708-019B960494DF}">
-                <a14:hiddenLine xmlns:a14="http://schemas.microsoft.com/office/drawing/2010/main" xmlns="" w="9525">
+                <a14:hiddenLine xmlns="" xmlns:a14="http://schemas.microsoft.com/office/drawing/2010/main" w="9525">
                   <a:solidFill>
                     <a:srgbClr val="000000"/>
                   </a:solidFill>
@@ -2515,7 +2515,7 @@
             </a:ln>
             <a:extLst>
               <a:ext uri="{91240B29-F687-4f45-9708-019B960494DF}">
-                <a14:hiddenLine xmlns:a14="http://schemas.microsoft.com/office/drawing/2010/main" xmlns="" w="9525">
+                <a14:hiddenLine xmlns="" xmlns:a14="http://schemas.microsoft.com/office/drawing/2010/main" w="9525">
                   <a:solidFill>
                     <a:srgbClr val="000000"/>
                   </a:solidFill>
@@ -2577,7 +2577,7 @@
             </a:ln>
             <a:extLst>
               <a:ext uri="{91240B29-F687-4f45-9708-019B960494DF}">
-                <a14:hiddenLine xmlns:a14="http://schemas.microsoft.com/office/drawing/2010/main" xmlns="" w="9525">
+                <a14:hiddenLine xmlns="" xmlns:a14="http://schemas.microsoft.com/office/drawing/2010/main" w="9525">
                   <a:solidFill>
                     <a:srgbClr val="000000"/>
                   </a:solidFill>
@@ -2667,7 +2667,7 @@
             </a:ln>
             <a:extLst>
               <a:ext uri="{91240B29-F687-4f45-9708-019B960494DF}">
-                <a14:hiddenLine xmlns:a14="http://schemas.microsoft.com/office/drawing/2010/main" xmlns="" w="9525">
+                <a14:hiddenLine xmlns="" xmlns:a14="http://schemas.microsoft.com/office/drawing/2010/main" w="9525">
                   <a:solidFill>
                     <a:srgbClr val="000000"/>
                   </a:solidFill>
@@ -2735,7 +2735,7 @@
             </a:ln>
             <a:extLst>
               <a:ext uri="{91240B29-F687-4f45-9708-019B960494DF}">
-                <a14:hiddenLine xmlns:a14="http://schemas.microsoft.com/office/drawing/2010/main" xmlns="" w="9525">
+                <a14:hiddenLine xmlns="" xmlns:a14="http://schemas.microsoft.com/office/drawing/2010/main" w="9525">
                   <a:solidFill>
                     <a:srgbClr val="000000"/>
                   </a:solidFill>
@@ -2797,7 +2797,7 @@
             </a:ln>
             <a:extLst>
               <a:ext uri="{91240B29-F687-4f45-9708-019B960494DF}">
-                <a14:hiddenLine xmlns:a14="http://schemas.microsoft.com/office/drawing/2010/main" xmlns="" w="9525">
+                <a14:hiddenLine xmlns="" xmlns:a14="http://schemas.microsoft.com/office/drawing/2010/main" w="9525">
                   <a:solidFill>
                     <a:srgbClr val="000000"/>
                   </a:solidFill>
@@ -2887,7 +2887,7 @@
             </a:ln>
             <a:extLst>
               <a:ext uri="{91240B29-F687-4f45-9708-019B960494DF}">
-                <a14:hiddenLine xmlns:a14="http://schemas.microsoft.com/office/drawing/2010/main" xmlns="" w="9525">
+                <a14:hiddenLine xmlns="" xmlns:a14="http://schemas.microsoft.com/office/drawing/2010/main" w="9525">
                   <a:solidFill>
                     <a:srgbClr val="000000"/>
                   </a:solidFill>
@@ -2949,7 +2949,7 @@
             </a:ln>
             <a:extLst>
               <a:ext uri="{91240B29-F687-4f45-9708-019B960494DF}">
-                <a14:hiddenLine xmlns:a14="http://schemas.microsoft.com/office/drawing/2010/main" xmlns="" w="9525">
+                <a14:hiddenLine xmlns="" xmlns:a14="http://schemas.microsoft.com/office/drawing/2010/main" w="9525">
                   <a:solidFill>
                     <a:srgbClr val="000000"/>
                   </a:solidFill>
@@ -3039,7 +3039,7 @@
             </a:ln>
             <a:extLst>
               <a:ext uri="{91240B29-F687-4f45-9708-019B960494DF}">
-                <a14:hiddenLine xmlns:a14="http://schemas.microsoft.com/office/drawing/2010/main" xmlns="" w="9525">
+                <a14:hiddenLine xmlns="" xmlns:a14="http://schemas.microsoft.com/office/drawing/2010/main" w="9525">
                   <a:solidFill>
                     <a:srgbClr val="000000"/>
                   </a:solidFill>
@@ -3101,7 +3101,7 @@
             </a:ln>
             <a:extLst>
               <a:ext uri="{91240B29-F687-4f45-9708-019B960494DF}">
-                <a14:hiddenLine xmlns:a14="http://schemas.microsoft.com/office/drawing/2010/main" xmlns="" w="9525">
+                <a14:hiddenLine xmlns="" xmlns:a14="http://schemas.microsoft.com/office/drawing/2010/main" w="9525">
                   <a:solidFill>
                     <a:srgbClr val="000000"/>
                   </a:solidFill>
@@ -3191,7 +3191,7 @@
             </a:ln>
             <a:extLst>
               <a:ext uri="{91240B29-F687-4f45-9708-019B960494DF}">
-                <a14:hiddenLine xmlns:a14="http://schemas.microsoft.com/office/drawing/2010/main" xmlns="" w="9525">
+                <a14:hiddenLine xmlns="" xmlns:a14="http://schemas.microsoft.com/office/drawing/2010/main" w="9525">
                   <a:solidFill>
                     <a:srgbClr val="000000"/>
                   </a:solidFill>
@@ -3225,7 +3225,7 @@
             </a:ln>
             <a:extLst>
               <a:ext uri="{91240B29-F687-4f45-9708-019B960494DF}">
-                <a14:hiddenLine xmlns:a14="http://schemas.microsoft.com/office/drawing/2010/main" xmlns="" w="9525">
+                <a14:hiddenLine xmlns="" xmlns:a14="http://schemas.microsoft.com/office/drawing/2010/main" w="9525">
                   <a:solidFill>
                     <a:srgbClr val="000000"/>
                   </a:solidFill>
@@ -3290,7 +3290,7 @@
             </a:ln>
             <a:extLst>
               <a:ext uri="{91240B29-F687-4f45-9708-019B960494DF}">
-                <a14:hiddenLine xmlns:a14="http://schemas.microsoft.com/office/drawing/2010/main" xmlns="" w="9525">
+                <a14:hiddenLine xmlns="" xmlns:a14="http://schemas.microsoft.com/office/drawing/2010/main" w="9525">
                   <a:solidFill>
                     <a:srgbClr val="000000"/>
                   </a:solidFill>
@@ -3380,7 +3380,7 @@
             </a:ln>
             <a:extLst>
               <a:ext uri="{91240B29-F687-4f45-9708-019B960494DF}">
-                <a14:hiddenLine xmlns:a14="http://schemas.microsoft.com/office/drawing/2010/main" xmlns="" w="9525">
+                <a14:hiddenLine xmlns="" xmlns:a14="http://schemas.microsoft.com/office/drawing/2010/main" w="9525">
                   <a:solidFill>
                     <a:srgbClr val="000000"/>
                   </a:solidFill>
@@ -3442,7 +3442,7 @@
             </a:ln>
             <a:extLst>
               <a:ext uri="{91240B29-F687-4f45-9708-019B960494DF}">
-                <a14:hiddenLine xmlns:a14="http://schemas.microsoft.com/office/drawing/2010/main" xmlns="" w="9525">
+                <a14:hiddenLine xmlns="" xmlns:a14="http://schemas.microsoft.com/office/drawing/2010/main" w="9525">
                   <a:solidFill>
                     <a:srgbClr val="000000"/>
                   </a:solidFill>
@@ -3532,7 +3532,7 @@
             </a:ln>
             <a:extLst>
               <a:ext uri="{91240B29-F687-4f45-9708-019B960494DF}">
-                <a14:hiddenLine xmlns:a14="http://schemas.microsoft.com/office/drawing/2010/main" xmlns="" w="9525">
+                <a14:hiddenLine xmlns="" xmlns:a14="http://schemas.microsoft.com/office/drawing/2010/main" w="9525">
                   <a:solidFill>
                     <a:srgbClr val="000000"/>
                   </a:solidFill>
@@ -3622,7 +3622,7 @@
             </a:ln>
             <a:extLst>
               <a:ext uri="{91240B29-F687-4f45-9708-019B960494DF}">
-                <a14:hiddenLine xmlns:a14="http://schemas.microsoft.com/office/drawing/2010/main" xmlns="" w="9525">
+                <a14:hiddenLine xmlns="" xmlns:a14="http://schemas.microsoft.com/office/drawing/2010/main" w="9525">
                   <a:solidFill>
                     <a:srgbClr val="000000"/>
                   </a:solidFill>
@@ -3687,7 +3687,7 @@
             </a:ln>
             <a:extLst>
               <a:ext uri="{91240B29-F687-4f45-9708-019B960494DF}">
-                <a14:hiddenLine xmlns:a14="http://schemas.microsoft.com/office/drawing/2010/main" xmlns="" w="9525">
+                <a14:hiddenLine xmlns="" xmlns:a14="http://schemas.microsoft.com/office/drawing/2010/main" w="9525">
                   <a:solidFill>
                     <a:srgbClr val="000000"/>
                   </a:solidFill>
@@ -3749,7 +3749,7 @@
             </a:ln>
             <a:extLst>
               <a:ext uri="{91240B29-F687-4f45-9708-019B960494DF}">
-                <a14:hiddenLine xmlns:a14="http://schemas.microsoft.com/office/drawing/2010/main" xmlns="" w="9525">
+                <a14:hiddenLine xmlns="" xmlns:a14="http://schemas.microsoft.com/office/drawing/2010/main" w="9525">
                   <a:solidFill>
                     <a:srgbClr val="000000"/>
                   </a:solidFill>
@@ -3839,7 +3839,7 @@
             </a:ln>
             <a:extLst>
               <a:ext uri="{91240B29-F687-4f45-9708-019B960494DF}">
-                <a14:hiddenLine xmlns:a14="http://schemas.microsoft.com/office/drawing/2010/main" xmlns="" w="9525">
+                <a14:hiddenLine xmlns="" xmlns:a14="http://schemas.microsoft.com/office/drawing/2010/main" w="9525">
                   <a:solidFill>
                     <a:srgbClr val="000000"/>
                   </a:solidFill>
@@ -3929,7 +3929,7 @@
             </a:ln>
             <a:extLst>
               <a:ext uri="{91240B29-F687-4f45-9708-019B960494DF}">
-                <a14:hiddenLine xmlns:a14="http://schemas.microsoft.com/office/drawing/2010/main" xmlns="" w="9525">
+                <a14:hiddenLine xmlns="" xmlns:a14="http://schemas.microsoft.com/office/drawing/2010/main" w="9525">
                   <a:solidFill>
                     <a:srgbClr val="000000"/>
                   </a:solidFill>
@@ -3991,7 +3991,7 @@
             </a:ln>
             <a:extLst>
               <a:ext uri="{91240B29-F687-4f45-9708-019B960494DF}">
-                <a14:hiddenLine xmlns:a14="http://schemas.microsoft.com/office/drawing/2010/main" xmlns="" w="9525">
+                <a14:hiddenLine xmlns="" xmlns:a14="http://schemas.microsoft.com/office/drawing/2010/main" w="9525">
                   <a:solidFill>
                     <a:srgbClr val="000000"/>
                   </a:solidFill>
@@ -4111,7 +4111,7 @@
             </a:ln>
             <a:extLst>
               <a:ext uri="{91240B29-F687-4f45-9708-019B960494DF}">
-                <a14:hiddenLine xmlns:a14="http://schemas.microsoft.com/office/drawing/2010/main" xmlns="" w="9525">
+                <a14:hiddenLine xmlns="" xmlns:a14="http://schemas.microsoft.com/office/drawing/2010/main" w="9525">
                   <a:solidFill>
                     <a:srgbClr val="000000"/>
                   </a:solidFill>
@@ -4179,7 +4179,7 @@
             </a:ln>
             <a:extLst>
               <a:ext uri="{91240B29-F687-4f45-9708-019B960494DF}">
-                <a14:hiddenLine xmlns:a14="http://schemas.microsoft.com/office/drawing/2010/main" xmlns="" w="9525">
+                <a14:hiddenLine xmlns="" xmlns:a14="http://schemas.microsoft.com/office/drawing/2010/main" w="9525">
                   <a:solidFill>
                     <a:srgbClr val="000000"/>
                   </a:solidFill>
@@ -4269,7 +4269,7 @@
             </a:ln>
             <a:extLst>
               <a:ext uri="{91240B29-F687-4f45-9708-019B960494DF}">
-                <a14:hiddenLine xmlns:a14="http://schemas.microsoft.com/office/drawing/2010/main" xmlns="" w="9525">
+                <a14:hiddenLine xmlns="" xmlns:a14="http://schemas.microsoft.com/office/drawing/2010/main" w="9525">
                   <a:solidFill>
                     <a:srgbClr val="000000"/>
                   </a:solidFill>
@@ -4409,7 +4409,7 @@
           <a:p>
             <a:fld id="{37D67B78-CFDB-4ECE-ADE6-BB76363CA169}" type="datetimeFigureOut">
               <a:rPr lang="en-US" smtClean="0"/>
-              <a:t>2/25/2021</a:t>
+              <a:t>11/6/2024</a:t>
             </a:fld>
             <a:endParaRPr lang="en-US"/>
           </a:p>
@@ -4676,7 +4676,7 @@
           <a:p>
             <a:fld id="{37D67B78-CFDB-4ECE-ADE6-BB76363CA169}" type="datetimeFigureOut">
               <a:rPr lang="en-US" smtClean="0"/>
-              <a:t>2/25/2021</a:t>
+              <a:t>11/6/2024</a:t>
             </a:fld>
             <a:endParaRPr lang="en-US"/>
           </a:p>
@@ -4872,7 +4872,7 @@
           <a:p>
             <a:fld id="{37D67B78-CFDB-4ECE-ADE6-BB76363CA169}" type="datetimeFigureOut">
               <a:rPr lang="en-US" smtClean="0"/>
-              <a:t>2/25/2021</a:t>
+              <a:t>11/6/2024</a:t>
             </a:fld>
             <a:endParaRPr lang="en-US"/>
           </a:p>
@@ -5135,7 +5135,7 @@
           <a:p>
             <a:fld id="{37D67B78-CFDB-4ECE-ADE6-BB76363CA169}" type="datetimeFigureOut">
               <a:rPr lang="en-US" smtClean="0"/>
-              <a:t>2/25/2021</a:t>
+              <a:t>11/6/2024</a:t>
             </a:fld>
             <a:endParaRPr lang="en-US"/>
           </a:p>
@@ -5569,7 +5569,7 @@
           <a:p>
             <a:fld id="{37D67B78-CFDB-4ECE-ADE6-BB76363CA169}" type="datetimeFigureOut">
               <a:rPr lang="en-US" smtClean="0"/>
-              <a:t>2/25/2021</a:t>
+              <a:t>11/6/2024</a:t>
             </a:fld>
             <a:endParaRPr lang="en-US"/>
           </a:p>
@@ -6115,7 +6115,7 @@
           <a:p>
             <a:fld id="{37D67B78-CFDB-4ECE-ADE6-BB76363CA169}" type="datetimeFigureOut">
               <a:rPr lang="en-US" smtClean="0"/>
-              <a:t>2/25/2021</a:t>
+              <a:t>11/6/2024</a:t>
             </a:fld>
             <a:endParaRPr lang="en-US"/>
           </a:p>
@@ -6835,7 +6835,7 @@
           <a:p>
             <a:fld id="{37D67B78-CFDB-4ECE-ADE6-BB76363CA169}" type="datetimeFigureOut">
               <a:rPr lang="en-US" smtClean="0"/>
-              <a:t>2/25/2021</a:t>
+              <a:t>11/6/2024</a:t>
             </a:fld>
             <a:endParaRPr lang="en-US"/>
           </a:p>
@@ -7005,7 +7005,7 @@
           <a:p>
             <a:fld id="{37D67B78-CFDB-4ECE-ADE6-BB76363CA169}" type="datetimeFigureOut">
               <a:rPr lang="en-US" smtClean="0"/>
-              <a:t>2/25/2021</a:t>
+              <a:t>11/6/2024</a:t>
             </a:fld>
             <a:endParaRPr lang="en-US"/>
           </a:p>
@@ -7185,7 +7185,7 @@
           <a:p>
             <a:fld id="{37D67B78-CFDB-4ECE-ADE6-BB76363CA169}" type="datetimeFigureOut">
               <a:rPr lang="en-US" smtClean="0"/>
-              <a:t>2/25/2021</a:t>
+              <a:t>11/6/2024</a:t>
             </a:fld>
             <a:endParaRPr lang="en-US"/>
           </a:p>
@@ -7355,7 +7355,7 @@
           <a:p>
             <a:fld id="{37D67B78-CFDB-4ECE-ADE6-BB76363CA169}" type="datetimeFigureOut">
               <a:rPr lang="en-US" smtClean="0"/>
-              <a:t>2/25/2021</a:t>
+              <a:t>11/6/2024</a:t>
             </a:fld>
             <a:endParaRPr lang="en-US"/>
           </a:p>
@@ -7605,7 +7605,7 @@
           <a:p>
             <a:fld id="{37D67B78-CFDB-4ECE-ADE6-BB76363CA169}" type="datetimeFigureOut">
               <a:rPr lang="en-US" smtClean="0"/>
-              <a:t>2/25/2021</a:t>
+              <a:t>11/6/2024</a:t>
             </a:fld>
             <a:endParaRPr lang="en-US"/>
           </a:p>
@@ -7837,7 +7837,7 @@
           <a:p>
             <a:fld id="{37D67B78-CFDB-4ECE-ADE6-BB76363CA169}" type="datetimeFigureOut">
               <a:rPr lang="en-US" smtClean="0"/>
-              <a:t>2/25/2021</a:t>
+              <a:t>11/6/2024</a:t>
             </a:fld>
             <a:endParaRPr lang="en-US"/>
           </a:p>
@@ -8223,7 +8223,7 @@
           <a:p>
             <a:fld id="{37D67B78-CFDB-4ECE-ADE6-BB76363CA169}" type="datetimeFigureOut">
               <a:rPr lang="en-US" smtClean="0"/>
-              <a:t>2/25/2021</a:t>
+              <a:t>11/6/2024</a:t>
             </a:fld>
             <a:endParaRPr lang="en-US"/>
           </a:p>
@@ -8346,7 +8346,7 @@
           <a:p>
             <a:fld id="{37D67B78-CFDB-4ECE-ADE6-BB76363CA169}" type="datetimeFigureOut">
               <a:rPr lang="en-US" smtClean="0"/>
-              <a:t>2/25/2021</a:t>
+              <a:t>11/6/2024</a:t>
             </a:fld>
             <a:endParaRPr lang="en-US"/>
           </a:p>
@@ -8441,7 +8441,7 @@
           <a:p>
             <a:fld id="{37D67B78-CFDB-4ECE-ADE6-BB76363CA169}" type="datetimeFigureOut">
               <a:rPr lang="en-US" smtClean="0"/>
-              <a:t>2/25/2021</a:t>
+              <a:t>11/6/2024</a:t>
             </a:fld>
             <a:endParaRPr lang="en-US"/>
           </a:p>
@@ -8690,7 +8690,7 @@
           <a:p>
             <a:fld id="{37D67B78-CFDB-4ECE-ADE6-BB76363CA169}" type="datetimeFigureOut">
               <a:rPr lang="en-US" smtClean="0"/>
-              <a:t>2/25/2021</a:t>
+              <a:t>11/6/2024</a:t>
             </a:fld>
             <a:endParaRPr lang="en-US"/>
           </a:p>
@@ -8975,7 +8975,7 @@
           <a:p>
             <a:fld id="{37D67B78-CFDB-4ECE-ADE6-BB76363CA169}" type="datetimeFigureOut">
               <a:rPr lang="en-US" smtClean="0"/>
-              <a:t>2/25/2021</a:t>
+              <a:t>11/6/2024</a:t>
             </a:fld>
             <a:endParaRPr lang="en-US"/>
           </a:p>
@@ -9098,7 +9098,7 @@
           <a:noFill/>
           <a:extLst>
             <a:ext uri="{909E8E84-426E-40dd-AFC4-6F175D3DCCD1}">
-              <a14:hiddenFill xmlns:a14="http://schemas.microsoft.com/office/drawing/2010/main" xmlns="">
+              <a14:hiddenFill xmlns="" xmlns:a14="http://schemas.microsoft.com/office/drawing/2010/main">
                 <a:solidFill>
                   <a:srgbClr val="FFFFFF"/>
                 </a:solidFill>
@@ -9172,7 +9172,7 @@
               </a:ln>
               <a:extLst>
                 <a:ext uri="{91240B29-F687-4f45-9708-019B960494DF}">
-                  <a14:hiddenLine xmlns:a14="http://schemas.microsoft.com/office/drawing/2010/main" xmlns="" w="9525">
+                  <a14:hiddenLine xmlns="" xmlns:a14="http://schemas.microsoft.com/office/drawing/2010/main" w="9525">
                     <a:solidFill>
                       <a:srgbClr val="000000"/>
                     </a:solidFill>
@@ -9262,7 +9262,7 @@
               </a:ln>
               <a:extLst>
                 <a:ext uri="{91240B29-F687-4f45-9708-019B960494DF}">
-                  <a14:hiddenLine xmlns:a14="http://schemas.microsoft.com/office/drawing/2010/main" xmlns="" w="9525">
+                  <a14:hiddenLine xmlns="" xmlns:a14="http://schemas.microsoft.com/office/drawing/2010/main" w="9525">
                     <a:solidFill>
                       <a:srgbClr val="000000"/>
                     </a:solidFill>
@@ -9352,7 +9352,7 @@
               </a:ln>
               <a:extLst>
                 <a:ext uri="{91240B29-F687-4f45-9708-019B960494DF}">
-                  <a14:hiddenLine xmlns:a14="http://schemas.microsoft.com/office/drawing/2010/main" xmlns="" w="9525">
+                  <a14:hiddenLine xmlns="" xmlns:a14="http://schemas.microsoft.com/office/drawing/2010/main" w="9525">
                     <a:solidFill>
                       <a:srgbClr val="000000"/>
                     </a:solidFill>
@@ -9414,7 +9414,7 @@
               </a:ln>
               <a:extLst>
                 <a:ext uri="{91240B29-F687-4f45-9708-019B960494DF}">
-                  <a14:hiddenLine xmlns:a14="http://schemas.microsoft.com/office/drawing/2010/main" xmlns="" w="9525">
+                  <a14:hiddenLine xmlns="" xmlns:a14="http://schemas.microsoft.com/office/drawing/2010/main" w="9525">
                     <a:solidFill>
                       <a:srgbClr val="000000"/>
                     </a:solidFill>
@@ -9504,7 +9504,7 @@
               </a:ln>
               <a:extLst>
                 <a:ext uri="{91240B29-F687-4f45-9708-019B960494DF}">
-                  <a14:hiddenLine xmlns:a14="http://schemas.microsoft.com/office/drawing/2010/main" xmlns="" w="9525">
+                  <a14:hiddenLine xmlns="" xmlns:a14="http://schemas.microsoft.com/office/drawing/2010/main" w="9525">
                     <a:solidFill>
                       <a:srgbClr val="000000"/>
                     </a:solidFill>
@@ -9566,7 +9566,7 @@
               </a:ln>
               <a:extLst>
                 <a:ext uri="{91240B29-F687-4f45-9708-019B960494DF}">
-                  <a14:hiddenLine xmlns:a14="http://schemas.microsoft.com/office/drawing/2010/main" xmlns="" w="9525">
+                  <a14:hiddenLine xmlns="" xmlns:a14="http://schemas.microsoft.com/office/drawing/2010/main" w="9525">
                     <a:solidFill>
                       <a:srgbClr val="000000"/>
                     </a:solidFill>
@@ -9628,7 +9628,7 @@
               </a:ln>
               <a:extLst>
                 <a:ext uri="{91240B29-F687-4f45-9708-019B960494DF}">
-                  <a14:hiddenLine xmlns:a14="http://schemas.microsoft.com/office/drawing/2010/main" xmlns="" w="9525">
+                  <a14:hiddenLine xmlns="" xmlns:a14="http://schemas.microsoft.com/office/drawing/2010/main" w="9525">
                     <a:solidFill>
                       <a:srgbClr val="000000"/>
                     </a:solidFill>
@@ -9718,7 +9718,7 @@
               </a:ln>
               <a:extLst>
                 <a:ext uri="{91240B29-F687-4f45-9708-019B960494DF}">
-                  <a14:hiddenLine xmlns:a14="http://schemas.microsoft.com/office/drawing/2010/main" xmlns="" w="9525">
+                  <a14:hiddenLine xmlns="" xmlns:a14="http://schemas.microsoft.com/office/drawing/2010/main" w="9525">
                     <a:solidFill>
                       <a:srgbClr val="000000"/>
                     </a:solidFill>
@@ -9808,7 +9808,7 @@
               </a:ln>
               <a:extLst>
                 <a:ext uri="{91240B29-F687-4f45-9708-019B960494DF}">
-                  <a14:hiddenLine xmlns:a14="http://schemas.microsoft.com/office/drawing/2010/main" xmlns="" w="9525">
+                  <a14:hiddenLine xmlns="" xmlns:a14="http://schemas.microsoft.com/office/drawing/2010/main" w="9525">
                     <a:solidFill>
                       <a:srgbClr val="000000"/>
                     </a:solidFill>
@@ -9870,7 +9870,7 @@
               </a:ln>
               <a:extLst>
                 <a:ext uri="{91240B29-F687-4f45-9708-019B960494DF}">
-                  <a14:hiddenLine xmlns:a14="http://schemas.microsoft.com/office/drawing/2010/main" xmlns="" w="9525">
+                  <a14:hiddenLine xmlns="" xmlns:a14="http://schemas.microsoft.com/office/drawing/2010/main" w="9525">
                     <a:solidFill>
                       <a:srgbClr val="000000"/>
                     </a:solidFill>
@@ -9980,7 +9980,7 @@
               </a:ln>
               <a:extLst>
                 <a:ext uri="{91240B29-F687-4f45-9708-019B960494DF}">
-                  <a14:hiddenLine xmlns:a14="http://schemas.microsoft.com/office/drawing/2010/main" xmlns="" w="9525">
+                  <a14:hiddenLine xmlns="" xmlns:a14="http://schemas.microsoft.com/office/drawing/2010/main" w="9525">
                     <a:solidFill>
                       <a:srgbClr val="000000"/>
                     </a:solidFill>
@@ -10064,7 +10064,7 @@
               </a:ln>
               <a:extLst>
                 <a:ext uri="{91240B29-F687-4f45-9708-019B960494DF}">
-                  <a14:hiddenLine xmlns:a14="http://schemas.microsoft.com/office/drawing/2010/main" xmlns="" w="9525">
+                  <a14:hiddenLine xmlns="" xmlns:a14="http://schemas.microsoft.com/office/drawing/2010/main" w="9525">
                     <a:solidFill>
                       <a:srgbClr val="000000"/>
                     </a:solidFill>
@@ -10126,7 +10126,7 @@
               </a:ln>
               <a:extLst>
                 <a:ext uri="{91240B29-F687-4f45-9708-019B960494DF}">
-                  <a14:hiddenLine xmlns:a14="http://schemas.microsoft.com/office/drawing/2010/main" xmlns="" w="9525">
+                  <a14:hiddenLine xmlns="" xmlns:a14="http://schemas.microsoft.com/office/drawing/2010/main" w="9525">
                     <a:solidFill>
                       <a:srgbClr val="000000"/>
                     </a:solidFill>
@@ -10188,7 +10188,7 @@
               </a:ln>
               <a:extLst>
                 <a:ext uri="{91240B29-F687-4f45-9708-019B960494DF}">
-                  <a14:hiddenLine xmlns:a14="http://schemas.microsoft.com/office/drawing/2010/main" xmlns="" w="9525">
+                  <a14:hiddenLine xmlns="" xmlns:a14="http://schemas.microsoft.com/office/drawing/2010/main" w="9525">
                     <a:solidFill>
                       <a:srgbClr val="000000"/>
                     </a:solidFill>
@@ -10278,7 +10278,7 @@
               </a:ln>
               <a:extLst>
                 <a:ext uri="{91240B29-F687-4f45-9708-019B960494DF}">
-                  <a14:hiddenLine xmlns:a14="http://schemas.microsoft.com/office/drawing/2010/main" xmlns="" w="9525">
+                  <a14:hiddenLine xmlns="" xmlns:a14="http://schemas.microsoft.com/office/drawing/2010/main" w="9525">
                     <a:solidFill>
                       <a:srgbClr val="000000"/>
                     </a:solidFill>
@@ -10312,7 +10312,7 @@
               </a:ln>
               <a:extLst>
                 <a:ext uri="{91240B29-F687-4f45-9708-019B960494DF}">
-                  <a14:hiddenLine xmlns:a14="http://schemas.microsoft.com/office/drawing/2010/main" xmlns="" w="9525">
+                  <a14:hiddenLine xmlns="" xmlns:a14="http://schemas.microsoft.com/office/drawing/2010/main" w="9525">
                     <a:solidFill>
                       <a:srgbClr val="000000"/>
                     </a:solidFill>
@@ -10377,7 +10377,7 @@
               </a:ln>
               <a:extLst>
                 <a:ext uri="{91240B29-F687-4f45-9708-019B960494DF}">
-                  <a14:hiddenLine xmlns:a14="http://schemas.microsoft.com/office/drawing/2010/main" xmlns="" w="9525">
+                  <a14:hiddenLine xmlns="" xmlns:a14="http://schemas.microsoft.com/office/drawing/2010/main" w="9525">
                     <a:solidFill>
                       <a:srgbClr val="000000"/>
                     </a:solidFill>
@@ -10467,7 +10467,7 @@
               </a:ln>
               <a:extLst>
                 <a:ext uri="{91240B29-F687-4f45-9708-019B960494DF}">
-                  <a14:hiddenLine xmlns:a14="http://schemas.microsoft.com/office/drawing/2010/main" xmlns="" w="9525">
+                  <a14:hiddenLine xmlns="" xmlns:a14="http://schemas.microsoft.com/office/drawing/2010/main" w="9525">
                     <a:solidFill>
                       <a:srgbClr val="000000"/>
                     </a:solidFill>
@@ -10529,7 +10529,7 @@
               </a:ln>
               <a:extLst>
                 <a:ext uri="{91240B29-F687-4f45-9708-019B960494DF}">
-                  <a14:hiddenLine xmlns:a14="http://schemas.microsoft.com/office/drawing/2010/main" xmlns="" w="9525">
+                  <a14:hiddenLine xmlns="" xmlns:a14="http://schemas.microsoft.com/office/drawing/2010/main" w="9525">
                     <a:solidFill>
                       <a:srgbClr val="000000"/>
                     </a:solidFill>
@@ -10619,7 +10619,7 @@
               </a:ln>
               <a:extLst>
                 <a:ext uri="{91240B29-F687-4f45-9708-019B960494DF}">
-                  <a14:hiddenLine xmlns:a14="http://schemas.microsoft.com/office/drawing/2010/main" xmlns="" w="9525">
+                  <a14:hiddenLine xmlns="" xmlns:a14="http://schemas.microsoft.com/office/drawing/2010/main" w="9525">
                     <a:solidFill>
                       <a:srgbClr val="000000"/>
                     </a:solidFill>
@@ -10684,7 +10684,7 @@
               </a:ln>
               <a:extLst>
                 <a:ext uri="{91240B29-F687-4f45-9708-019B960494DF}">
-                  <a14:hiddenLine xmlns:a14="http://schemas.microsoft.com/office/drawing/2010/main" xmlns="" w="9525">
+                  <a14:hiddenLine xmlns="" xmlns:a14="http://schemas.microsoft.com/office/drawing/2010/main" w="9525">
                     <a:solidFill>
                       <a:srgbClr val="000000"/>
                     </a:solidFill>
@@ -10746,7 +10746,7 @@
               </a:ln>
               <a:extLst>
                 <a:ext uri="{91240B29-F687-4f45-9708-019B960494DF}">
-                  <a14:hiddenLine xmlns:a14="http://schemas.microsoft.com/office/drawing/2010/main" xmlns="" w="9525">
+                  <a14:hiddenLine xmlns="" xmlns:a14="http://schemas.microsoft.com/office/drawing/2010/main" w="9525">
                     <a:solidFill>
                       <a:srgbClr val="000000"/>
                     </a:solidFill>
@@ -10836,7 +10836,7 @@
               </a:ln>
               <a:extLst>
                 <a:ext uri="{91240B29-F687-4f45-9708-019B960494DF}">
-                  <a14:hiddenLine xmlns:a14="http://schemas.microsoft.com/office/drawing/2010/main" xmlns="" w="9525">
+                  <a14:hiddenLine xmlns="" xmlns:a14="http://schemas.microsoft.com/office/drawing/2010/main" w="9525">
                     <a:solidFill>
                       <a:srgbClr val="000000"/>
                     </a:solidFill>
@@ -10926,7 +10926,7 @@
               </a:ln>
               <a:extLst>
                 <a:ext uri="{91240B29-F687-4f45-9708-019B960494DF}">
-                  <a14:hiddenLine xmlns:a14="http://schemas.microsoft.com/office/drawing/2010/main" xmlns="" w="9525">
+                  <a14:hiddenLine xmlns="" xmlns:a14="http://schemas.microsoft.com/office/drawing/2010/main" w="9525">
                     <a:solidFill>
                       <a:srgbClr val="000000"/>
                     </a:solidFill>
@@ -10991,7 +10991,7 @@
               </a:ln>
               <a:extLst>
                 <a:ext uri="{91240B29-F687-4f45-9708-019B960494DF}">
-                  <a14:hiddenLine xmlns:a14="http://schemas.microsoft.com/office/drawing/2010/main" xmlns="" w="9525">
+                  <a14:hiddenLine xmlns="" xmlns:a14="http://schemas.microsoft.com/office/drawing/2010/main" w="9525">
                     <a:solidFill>
                       <a:srgbClr val="000000"/>
                     </a:solidFill>
@@ -11111,7 +11111,7 @@
               </a:ln>
               <a:extLst>
                 <a:ext uri="{91240B29-F687-4f45-9708-019B960494DF}">
-                  <a14:hiddenLine xmlns:a14="http://schemas.microsoft.com/office/drawing/2010/main" xmlns="" w="9525">
+                  <a14:hiddenLine xmlns="" xmlns:a14="http://schemas.microsoft.com/office/drawing/2010/main" w="9525">
                     <a:solidFill>
                       <a:srgbClr val="000000"/>
                     </a:solidFill>
@@ -11209,7 +11209,7 @@
               </a:ln>
               <a:extLst>
                 <a:ext uri="{91240B29-F687-4f45-9708-019B960494DF}">
-                  <a14:hiddenLine xmlns:a14="http://schemas.microsoft.com/office/drawing/2010/main" xmlns="" w="9525">
+                  <a14:hiddenLine xmlns="" xmlns:a14="http://schemas.microsoft.com/office/drawing/2010/main" w="9525">
                     <a:solidFill>
                       <a:srgbClr val="000000"/>
                     </a:solidFill>
@@ -11324,7 +11324,7 @@
               </a:ln>
               <a:extLst>
                 <a:ext uri="{91240B29-F687-4f45-9708-019B960494DF}">
-                  <a14:hiddenLine xmlns:a14="http://schemas.microsoft.com/office/drawing/2010/main" xmlns="" w="9525">
+                  <a14:hiddenLine xmlns="" xmlns:a14="http://schemas.microsoft.com/office/drawing/2010/main" w="9525">
                     <a:solidFill>
                       <a:srgbClr val="000000"/>
                     </a:solidFill>
@@ -11414,7 +11414,7 @@
               </a:ln>
               <a:extLst>
                 <a:ext uri="{91240B29-F687-4f45-9708-019B960494DF}">
-                  <a14:hiddenLine xmlns:a14="http://schemas.microsoft.com/office/drawing/2010/main" xmlns="" w="9525">
+                  <a14:hiddenLine xmlns="" xmlns:a14="http://schemas.microsoft.com/office/drawing/2010/main" w="9525">
                     <a:solidFill>
                       <a:srgbClr val="000000"/>
                     </a:solidFill>
@@ -11479,7 +11479,7 @@
               </a:ln>
               <a:extLst>
                 <a:ext uri="{91240B29-F687-4f45-9708-019B960494DF}">
-                  <a14:hiddenLine xmlns:a14="http://schemas.microsoft.com/office/drawing/2010/main" xmlns="" w="9525">
+                  <a14:hiddenLine xmlns="" xmlns:a14="http://schemas.microsoft.com/office/drawing/2010/main" w="9525">
                     <a:solidFill>
                       <a:srgbClr val="000000"/>
                     </a:solidFill>
@@ -11569,7 +11569,7 @@
               </a:ln>
               <a:extLst>
                 <a:ext uri="{91240B29-F687-4f45-9708-019B960494DF}">
-                  <a14:hiddenLine xmlns:a14="http://schemas.microsoft.com/office/drawing/2010/main" xmlns="" w="9525">
+                  <a14:hiddenLine xmlns="" xmlns:a14="http://schemas.microsoft.com/office/drawing/2010/main" w="9525">
                     <a:solidFill>
                       <a:srgbClr val="000000"/>
                     </a:solidFill>
@@ -11637,7 +11637,7 @@
               </a:ln>
               <a:extLst>
                 <a:ext uri="{91240B29-F687-4f45-9708-019B960494DF}">
-                  <a14:hiddenLine xmlns:a14="http://schemas.microsoft.com/office/drawing/2010/main" xmlns="" w="9525">
+                  <a14:hiddenLine xmlns="" xmlns:a14="http://schemas.microsoft.com/office/drawing/2010/main" w="9525">
                     <a:solidFill>
                       <a:srgbClr val="000000"/>
                     </a:solidFill>
@@ -11727,7 +11727,7 @@
               </a:ln>
               <a:extLst>
                 <a:ext uri="{91240B29-F687-4f45-9708-019B960494DF}">
-                  <a14:hiddenLine xmlns:a14="http://schemas.microsoft.com/office/drawing/2010/main" xmlns="" w="9525">
+                  <a14:hiddenLine xmlns="" xmlns:a14="http://schemas.microsoft.com/office/drawing/2010/main" w="9525">
                     <a:solidFill>
                       <a:srgbClr val="000000"/>
                     </a:solidFill>
@@ -11795,7 +11795,7 @@
               </a:ln>
               <a:extLst>
                 <a:ext uri="{91240B29-F687-4f45-9708-019B960494DF}">
-                  <a14:hiddenLine xmlns:a14="http://schemas.microsoft.com/office/drawing/2010/main" xmlns="" w="9525">
+                  <a14:hiddenLine xmlns="" xmlns:a14="http://schemas.microsoft.com/office/drawing/2010/main" w="9525">
                     <a:solidFill>
                       <a:srgbClr val="000000"/>
                     </a:solidFill>
@@ -11885,7 +11885,7 @@
               </a:ln>
               <a:extLst>
                 <a:ext uri="{91240B29-F687-4f45-9708-019B960494DF}">
-                  <a14:hiddenLine xmlns:a14="http://schemas.microsoft.com/office/drawing/2010/main" xmlns="" w="9525">
+                  <a14:hiddenLine xmlns="" xmlns:a14="http://schemas.microsoft.com/office/drawing/2010/main" w="9525">
                     <a:solidFill>
                       <a:srgbClr val="000000"/>
                     </a:solidFill>
@@ -11919,7 +11919,7 @@
               </a:ln>
               <a:extLst>
                 <a:ext uri="{91240B29-F687-4f45-9708-019B960494DF}">
-                  <a14:hiddenLine xmlns:a14="http://schemas.microsoft.com/office/drawing/2010/main" xmlns="" w="9525">
+                  <a14:hiddenLine xmlns="" xmlns:a14="http://schemas.microsoft.com/office/drawing/2010/main" w="9525">
                     <a:solidFill>
                       <a:srgbClr val="000000"/>
                     </a:solidFill>
@@ -12059,7 +12059,7 @@
           <a:p>
             <a:fld id="{37D67B78-CFDB-4ECE-ADE6-BB76363CA169}" type="datetimeFigureOut">
               <a:rPr lang="en-US" smtClean="0"/>
-              <a:t>2/25/2021</a:t>
+              <a:t>11/6/2024</a:t>
             </a:fld>
             <a:endParaRPr lang="en-US"/>
           </a:p>
@@ -22632,7 +22632,7 @@
         </p:nvSpPr>
         <p:spPr>
           <a:xfrm>
-            <a:off x="8830224" y="4235445"/>
+            <a:off x="1692599" y="4545644"/>
             <a:ext cx="1764667" cy="895007"/>
           </a:xfrm>
           <a:prstGeom prst="rect">
@@ -22716,7 +22716,7 @@
         </p:blipFill>
         <p:spPr>
           <a:xfrm>
-            <a:off x="9907282" y="4506578"/>
+            <a:off x="2776056" y="4799094"/>
             <a:ext cx="482136" cy="388108"/>
           </a:xfrm>
           <a:prstGeom prst="rect">
@@ -22745,7 +22745,7 @@
         </p:blipFill>
         <p:spPr>
           <a:xfrm>
-            <a:off x="9043683" y="4435411"/>
+            <a:off x="1912457" y="4727927"/>
             <a:ext cx="348090" cy="646215"/>
           </a:xfrm>
           <a:prstGeom prst="rect">
@@ -22774,7 +22774,7 @@
         </p:blipFill>
         <p:spPr>
           <a:xfrm>
-            <a:off x="9554216" y="4506578"/>
+            <a:off x="2422990" y="4799094"/>
             <a:ext cx="303886" cy="503880"/>
           </a:xfrm>
           <a:prstGeom prst="rect">
@@ -22782,6 +22782,288 @@
           </a:prstGeom>
         </p:spPr>
       </p:pic>
+      <p:sp>
+        <p:nvSpPr>
+          <p:cNvPr id="2" name="Rectangle 1">
+            <a:extLst>
+              <a:ext uri="{FF2B5EF4-FFF2-40B4-BE49-F238E27FC236}">
+                <a16:creationId xmlns:a16="http://schemas.microsoft.com/office/drawing/2014/main" id="{973E5A39-4816-7031-F93A-72CE465A86C0}"/>
+              </a:ext>
+            </a:extLst>
+          </p:cNvPr>
+          <p:cNvSpPr/>
+          <p:nvPr/>
+        </p:nvSpPr>
+        <p:spPr>
+          <a:xfrm>
+            <a:off x="8490200" y="4164801"/>
+            <a:ext cx="777194" cy="761683"/>
+          </a:xfrm>
+          <a:prstGeom prst="rect">
+            <a:avLst/>
+          </a:prstGeom>
+          <a:ln>
+            <a:noFill/>
+          </a:ln>
+          <a:effectLst>
+            <a:outerShdw blurRad="190500" dist="190500" dir="3000000" algn="l" rotWithShape="0">
+              <a:prstClr val="black">
+                <a:alpha val="40000"/>
+              </a:prstClr>
+            </a:outerShdw>
+          </a:effectLst>
+          <a:scene3d>
+            <a:camera prst="orthographicFront"/>
+            <a:lightRig rig="threePt" dir="t"/>
+          </a:scene3d>
+          <a:sp3d>
+            <a:bevelT w="228600" h="69850"/>
+            <a:bevelB w="152400" h="50800" prst="softRound"/>
+          </a:sp3d>
+        </p:spPr>
+        <p:style>
+          <a:lnRef idx="2">
+            <a:schemeClr val="accent1">
+              <a:shade val="50000"/>
+            </a:schemeClr>
+          </a:lnRef>
+          <a:fillRef idx="1">
+            <a:schemeClr val="accent1"/>
+          </a:fillRef>
+          <a:effectRef idx="0">
+            <a:schemeClr val="accent1"/>
+          </a:effectRef>
+          <a:fontRef idx="minor">
+            <a:schemeClr val="lt1"/>
+          </a:fontRef>
+        </p:style>
+        <p:txBody>
+          <a:bodyPr rtlCol="0" anchor="ctr">
+            <a:sp3d>
+              <a:bevelB w="69850" prst="coolSlant"/>
+            </a:sp3d>
+          </a:bodyPr>
+          <a:lstStyle/>
+          <a:p>
+            <a:pPr algn="ctr"/>
+            <a:r>
+              <a:rPr lang="bn-IN" sz="4400" b="1" dirty="0">
+                <a:solidFill>
+                  <a:schemeClr val="bg1"/>
+                </a:solidFill>
+                <a:effectLst>
+                  <a:outerShdw sx="1000" sy="1000" algn="ctr" rotWithShape="0">
+                    <a:srgbClr val="000000"/>
+                  </a:outerShdw>
+                </a:effectLst>
+                <a:latin typeface="Kalpurush" panose="02000600000000000000" pitchFamily="2" charset="0"/>
+                <a:cs typeface="Kalpurush" panose="02000600000000000000" pitchFamily="2" charset="0"/>
+              </a:rPr>
+              <a:t>ৎ</a:t>
+            </a:r>
+            <a:endParaRPr lang="en-US" sz="4400" b="1" dirty="0">
+              <a:solidFill>
+                <a:schemeClr val="bg1"/>
+              </a:solidFill>
+              <a:effectLst>
+                <a:outerShdw sx="1000" sy="1000" algn="ctr" rotWithShape="0">
+                  <a:srgbClr val="000000"/>
+                </a:outerShdw>
+              </a:effectLst>
+              <a:latin typeface="Kalpurush" panose="02000600000000000000" pitchFamily="2" charset="0"/>
+              <a:cs typeface="Kalpurush" panose="02000600000000000000" pitchFamily="2" charset="0"/>
+            </a:endParaRPr>
+          </a:p>
+        </p:txBody>
+      </p:sp>
+      <p:sp>
+        <p:nvSpPr>
+          <p:cNvPr id="5" name="Rectangle 4">
+            <a:extLst>
+              <a:ext uri="{FF2B5EF4-FFF2-40B4-BE49-F238E27FC236}">
+                <a16:creationId xmlns:a16="http://schemas.microsoft.com/office/drawing/2014/main" id="{998AF574-0702-153C-8AE3-1AEC6717BA81}"/>
+              </a:ext>
+            </a:extLst>
+          </p:cNvPr>
+          <p:cNvSpPr/>
+          <p:nvPr/>
+        </p:nvSpPr>
+        <p:spPr>
+          <a:xfrm>
+            <a:off x="10547338" y="4164800"/>
+            <a:ext cx="777194" cy="761683"/>
+          </a:xfrm>
+          <a:prstGeom prst="rect">
+            <a:avLst/>
+          </a:prstGeom>
+          <a:ln>
+            <a:noFill/>
+          </a:ln>
+          <a:effectLst>
+            <a:outerShdw blurRad="190500" dist="190500" dir="3000000" algn="l" rotWithShape="0">
+              <a:prstClr val="black">
+                <a:alpha val="40000"/>
+              </a:prstClr>
+            </a:outerShdw>
+          </a:effectLst>
+          <a:scene3d>
+            <a:camera prst="orthographicFront"/>
+            <a:lightRig rig="threePt" dir="t"/>
+          </a:scene3d>
+          <a:sp3d>
+            <a:bevelT w="228600" h="69850"/>
+            <a:bevelB w="152400" h="50800" prst="softRound"/>
+          </a:sp3d>
+        </p:spPr>
+        <p:style>
+          <a:lnRef idx="2">
+            <a:schemeClr val="accent1">
+              <a:shade val="50000"/>
+            </a:schemeClr>
+          </a:lnRef>
+          <a:fillRef idx="1">
+            <a:schemeClr val="accent1"/>
+          </a:fillRef>
+          <a:effectRef idx="0">
+            <a:schemeClr val="accent1"/>
+          </a:effectRef>
+          <a:fontRef idx="minor">
+            <a:schemeClr val="lt1"/>
+          </a:fontRef>
+        </p:style>
+        <p:txBody>
+          <a:bodyPr rtlCol="0" anchor="ctr">
+            <a:sp3d>
+              <a:bevelB w="69850" prst="coolSlant"/>
+            </a:sp3d>
+          </a:bodyPr>
+          <a:lstStyle/>
+          <a:p>
+            <a:pPr algn="ctr"/>
+            <a:r>
+              <a:rPr lang="bn-IN" sz="4400" b="1" dirty="0">
+                <a:solidFill>
+                  <a:schemeClr val="bg1"/>
+                </a:solidFill>
+                <a:effectLst>
+                  <a:outerShdw sx="1000" sy="1000" algn="ctr" rotWithShape="0">
+                    <a:srgbClr val="000000"/>
+                  </a:outerShdw>
+                </a:effectLst>
+                <a:latin typeface="Kalpurush" panose="02000600000000000000" pitchFamily="2" charset="0"/>
+                <a:cs typeface="Kalpurush" panose="02000600000000000000" pitchFamily="2" charset="0"/>
+              </a:rPr>
+              <a:t>ৎ</a:t>
+            </a:r>
+            <a:endParaRPr lang="en-US" sz="4400" b="1" dirty="0">
+              <a:solidFill>
+                <a:schemeClr val="bg1"/>
+              </a:solidFill>
+              <a:effectLst>
+                <a:outerShdw sx="1000" sy="1000" algn="ctr" rotWithShape="0">
+                  <a:srgbClr val="000000"/>
+                </a:outerShdw>
+              </a:effectLst>
+              <a:latin typeface="Kalpurush" panose="02000600000000000000" pitchFamily="2" charset="0"/>
+              <a:cs typeface="Kalpurush" panose="02000600000000000000" pitchFamily="2" charset="0"/>
+            </a:endParaRPr>
+          </a:p>
+        </p:txBody>
+      </p:sp>
+      <p:sp>
+        <p:nvSpPr>
+          <p:cNvPr id="8" name="Rectangle 7">
+            <a:extLst>
+              <a:ext uri="{FF2B5EF4-FFF2-40B4-BE49-F238E27FC236}">
+                <a16:creationId xmlns:a16="http://schemas.microsoft.com/office/drawing/2014/main" id="{7565DA87-16B7-D840-ED33-DF1570063551}"/>
+              </a:ext>
+            </a:extLst>
+          </p:cNvPr>
+          <p:cNvSpPr/>
+          <p:nvPr/>
+        </p:nvSpPr>
+        <p:spPr>
+          <a:xfrm>
+            <a:off x="9345264" y="5181397"/>
+            <a:ext cx="777194" cy="761683"/>
+          </a:xfrm>
+          <a:prstGeom prst="rect">
+            <a:avLst/>
+          </a:prstGeom>
+          <a:ln>
+            <a:noFill/>
+          </a:ln>
+          <a:effectLst>
+            <a:outerShdw blurRad="190500" dist="190500" dir="3000000" algn="l" rotWithShape="0">
+              <a:prstClr val="black">
+                <a:alpha val="40000"/>
+              </a:prstClr>
+            </a:outerShdw>
+          </a:effectLst>
+          <a:scene3d>
+            <a:camera prst="orthographicFront"/>
+            <a:lightRig rig="threePt" dir="t"/>
+          </a:scene3d>
+          <a:sp3d>
+            <a:bevelT w="228600" h="69850"/>
+            <a:bevelB w="152400" h="50800" prst="softRound"/>
+          </a:sp3d>
+        </p:spPr>
+        <p:style>
+          <a:lnRef idx="2">
+            <a:schemeClr val="accent1">
+              <a:shade val="50000"/>
+            </a:schemeClr>
+          </a:lnRef>
+          <a:fillRef idx="1">
+            <a:schemeClr val="accent1"/>
+          </a:fillRef>
+          <a:effectRef idx="0">
+            <a:schemeClr val="accent1"/>
+          </a:effectRef>
+          <a:fontRef idx="minor">
+            <a:schemeClr val="lt1"/>
+          </a:fontRef>
+        </p:style>
+        <p:txBody>
+          <a:bodyPr rtlCol="0" anchor="ctr">
+            <a:sp3d>
+              <a:bevelB w="69850" prst="coolSlant"/>
+            </a:sp3d>
+          </a:bodyPr>
+          <a:lstStyle/>
+          <a:p>
+            <a:pPr algn="ctr"/>
+            <a:r>
+              <a:rPr lang="bn-IN" sz="4400" b="1" dirty="0">
+                <a:solidFill>
+                  <a:schemeClr val="bg1"/>
+                </a:solidFill>
+                <a:effectLst>
+                  <a:outerShdw sx="1000" sy="1000" algn="ctr" rotWithShape="0">
+                    <a:srgbClr val="000000"/>
+                  </a:outerShdw>
+                </a:effectLst>
+                <a:latin typeface="Kalpurush" panose="02000600000000000000" pitchFamily="2" charset="0"/>
+                <a:cs typeface="Kalpurush" panose="02000600000000000000" pitchFamily="2" charset="0"/>
+              </a:rPr>
+              <a:t>ৎ</a:t>
+            </a:r>
+            <a:endParaRPr lang="en-US" sz="4400" b="1" dirty="0">
+              <a:solidFill>
+                <a:schemeClr val="bg1"/>
+              </a:solidFill>
+              <a:effectLst>
+                <a:outerShdw sx="1000" sy="1000" algn="ctr" rotWithShape="0">
+                  <a:srgbClr val="000000"/>
+                </a:outerShdw>
+              </a:effectLst>
+              <a:latin typeface="Kalpurush" panose="02000600000000000000" pitchFamily="2" charset="0"/>
+              <a:cs typeface="Kalpurush" panose="02000600000000000000" pitchFamily="2" charset="0"/>
+            </a:endParaRPr>
+          </a:p>
+        </p:txBody>
+      </p:sp>
     </p:spTree>
     <p:extLst>
       <p:ext uri="{BB962C8B-B14F-4D97-AF65-F5344CB8AC3E}">

</xml_diff>